<commit_message>
build+slides: disable admin password rotation for the demo; regen deck
- .env.example: PASSWORD_CHANGE_ENFORCEMENT_ENABLED=false — ContextForge forces
  the bootstrapped admin to rotate its password on first UI login, a stage
  blocker. Complexity policy stays on; we just don't force a rotation.
- slides: regenerate the deck (20 slides) with Codespaces one-click + a pointer
  to the captured evidence in the speaker notes.

Co-Authored-By: Claude Opus 4.8 (1M context) <noreply@anthropic.com>
</commit_message>
<xml_diff>
--- a/slides/bob-controlplane-talk.pptx
+++ b/slides/bob-controlplane-talk.pptx
@@ -1022,6 +1022,22 @@
               <a:t>Say it: "You didn't watch a slideware mesh. You built it - and it's provable."</a:t>
             </a:r>
           </a:p>
+          <a:p/>
+          <a:p>
+            <a:r>
+              <a:t>CAPTURED PROOF: docs/evidence/index.html - the whole run (build → govern → 4 controls)</a:t>
+            </a:r>
+          </a:p>
+          <a:p>
+            <a:r>
+              <a:t>with real gateway responses + Admin-UI screenshots + the 16/16 suite output. Open it</a:t>
+            </a:r>
+          </a:p>
+          <a:p>
+            <a:r>
+              <a:t>if a control ever refuses to fire live. Stage runbook: docs/dev-day-runsheet.md.</a:t>
+            </a:r>
+          </a:p>
         </p:txBody>
       </p:sp>
       <p:sp>
@@ -1835,6 +1851,32 @@
           <a:p>
             <a:r>
               <a:t>whole governed mesh with ONLY Bob installed - governance holds over the wire.</a:t>
+            </a:r>
+          </a:p>
+          <a:p/>
+          <a:p>
+            <a:r>
+              <a:t>CAN'T RUN IT LOCALLY? One-click "Open in GitHub Codespaces" badge in the README</a:t>
+            </a:r>
+          </a:p>
+          <a:p>
+            <a:r>
+              <a:t>(codespaces.new/manavgup/ai-agent-controlplane-demo) - the devcontainer auto-runs</a:t>
+            </a:r>
+          </a:p>
+          <a:p>
+            <a:r>
+              <a:t>`make up &amp;&amp; make seed` in the cloud; make port 4444 Public, then `make connect`.</a:t>
+            </a:r>
+          </a:p>
+          <a:p>
+            <a:r>
+              <a:t>GOTCHA: use the `-t http` + `/mcp` form (never SSE - Codespaces proxies buffer SSE,</a:t>
+            </a:r>
+          </a:p>
+          <a:p>
+            <a:r>
+              <a:t>so Bob hangs on connect). Tier 2 in docs/ONBOARDING.md.</a:t>
             </a:r>
           </a:p>
         </p:txBody>

</xml_diff>

<commit_message>
fix(slides): keep the architecture diagram when matplotlib is absent
The Mesh slide (④) gated the diagram embed on render_architecture_png()
succeeding, so a build without matplotlib fell back to bare server boxes
and dropped the diagram (regression when rebuilt via bare --with
python-pptx). Now have_png also accepts the committed
slides/assets/architecture.png as a fallback, and the documented build
command pins matplotlib + pillow for the fresh render.

Co-Authored-By: Claude Opus 4.8 (1M context) <noreply@anthropic.com>
</commit_message>
<xml_diff>
--- a/slides/bob-controlplane-talk.pptx
+++ b/slides/bob-controlplane-talk.pptx
@@ -9903,567 +9903,33 @@
           </a:p>
         </p:txBody>
       </p:sp>
-      <p:sp>
-        <p:nvSpPr>
-          <p:cNvPr id="7" name="Rounded Rectangle 6"/>
-          <p:cNvSpPr/>
-          <p:nvPr/>
-        </p:nvSpPr>
-        <p:spPr>
-          <a:xfrm>
-            <a:off x="7680960" y="2011680"/>
-            <a:ext cx="3840480" cy="457200"/>
-          </a:xfrm>
-          <a:prstGeom prst="roundRect">
-            <a:avLst>
-              <a:gd name="adj" fmla="val 6000"/>
-            </a:avLst>
-          </a:prstGeom>
-          <a:solidFill>
-            <a:srgbClr val="F2F4F8"/>
-          </a:solidFill>
-          <a:ln w="12700">
-            <a:solidFill>
-              <a:srgbClr val="D0D7E2"/>
-            </a:solidFill>
-          </a:ln>
-          <a:effectLst/>
-        </p:spPr>
-        <p:style>
-          <a:lnRef idx="1">
-            <a:schemeClr val="accent1"/>
-          </a:lnRef>
-          <a:fillRef idx="3">
-            <a:schemeClr val="accent1"/>
-          </a:fillRef>
-          <a:effectRef idx="2">
-            <a:schemeClr val="accent1"/>
-          </a:effectRef>
-          <a:fontRef idx="minor">
-            <a:schemeClr val="lt1"/>
-          </a:fontRef>
-        </p:style>
-        <p:txBody>
-          <a:bodyPr rtlCol="0" anchor="ctr"/>
-          <a:lstStyle/>
-          <a:p>
-            <a:pPr algn="ctr"/>
-          </a:p>
-        </p:txBody>
-      </p:sp>
-      <p:sp>
-        <p:nvSpPr>
-          <p:cNvPr id="8" name="TextBox 7"/>
-          <p:cNvSpPr txBox="1"/>
-          <p:nvPr/>
-        </p:nvSpPr>
-        <p:spPr>
-          <a:xfrm>
-            <a:off x="7863840" y="2048256"/>
-            <a:ext cx="3566160" cy="384048"/>
-          </a:xfrm>
-          <a:prstGeom prst="rect">
-            <a:avLst/>
-          </a:prstGeom>
-          <a:noFill/>
-        </p:spPr>
-        <p:txBody>
-          <a:bodyPr wrap="square" anchor="ctr" lIns="0" rIns="0" tIns="0" bIns="0">
-            <a:spAutoFit/>
-          </a:bodyPr>
-          <a:lstStyle/>
-          <a:p>
-            <a:pPr algn="l">
-              <a:lnSpc>
-                <a:spcPct val="100000"/>
-              </a:lnSpc>
-              <a:spcBef>
-                <a:spcPts val="0"/>
-              </a:spcBef>
-              <a:spcAft>
-                <a:spcPts val="400"/>
-              </a:spcAft>
-            </a:pPr>
-            <a:r>
-              <a:rPr sz="1200" b="1" i="0">
-                <a:solidFill>
-                  <a:srgbClr val="161616"/>
-                </a:solidFill>
-                <a:latin typeface="Consolas"/>
-              </a:rPr>
-              <a:t>expense-db</a:t>
-            </a:r>
-          </a:p>
-        </p:txBody>
-      </p:sp>
-      <p:sp>
-        <p:nvSpPr>
-          <p:cNvPr id="9" name="Rounded Rectangle 8"/>
-          <p:cNvSpPr/>
-          <p:nvPr/>
-        </p:nvSpPr>
-        <p:spPr>
-          <a:xfrm>
-            <a:off x="7680960" y="2578608"/>
-            <a:ext cx="3840480" cy="457200"/>
-          </a:xfrm>
-          <a:prstGeom prst="roundRect">
-            <a:avLst>
-              <a:gd name="adj" fmla="val 6000"/>
-            </a:avLst>
-          </a:prstGeom>
-          <a:solidFill>
-            <a:srgbClr val="F2F4F8"/>
-          </a:solidFill>
-          <a:ln w="12700">
-            <a:solidFill>
-              <a:srgbClr val="D0D7E2"/>
-            </a:solidFill>
-          </a:ln>
-          <a:effectLst/>
-        </p:spPr>
-        <p:style>
-          <a:lnRef idx="1">
-            <a:schemeClr val="accent1"/>
-          </a:lnRef>
-          <a:fillRef idx="3">
-            <a:schemeClr val="accent1"/>
-          </a:fillRef>
-          <a:effectRef idx="2">
-            <a:schemeClr val="accent1"/>
-          </a:effectRef>
-          <a:fontRef idx="minor">
-            <a:schemeClr val="lt1"/>
-          </a:fontRef>
-        </p:style>
-        <p:txBody>
-          <a:bodyPr rtlCol="0" anchor="ctr"/>
-          <a:lstStyle/>
-          <a:p>
-            <a:pPr algn="ctr"/>
-          </a:p>
-        </p:txBody>
-      </p:sp>
-      <p:sp>
-        <p:nvSpPr>
-          <p:cNvPr id="10" name="TextBox 9"/>
-          <p:cNvSpPr txBox="1"/>
-          <p:nvPr/>
-        </p:nvSpPr>
-        <p:spPr>
-          <a:xfrm>
-            <a:off x="7863840" y="2615184"/>
-            <a:ext cx="3566160" cy="384048"/>
-          </a:xfrm>
-          <a:prstGeom prst="rect">
-            <a:avLst/>
-          </a:prstGeom>
-          <a:noFill/>
-        </p:spPr>
-        <p:txBody>
-          <a:bodyPr wrap="square" anchor="ctr" lIns="0" rIns="0" tIns="0" bIns="0">
-            <a:spAutoFit/>
-          </a:bodyPr>
-          <a:lstStyle/>
-          <a:p>
-            <a:pPr algn="l">
-              <a:lnSpc>
-                <a:spcPct val="100000"/>
-              </a:lnSpc>
-              <a:spcBef>
-                <a:spcPts val="0"/>
-              </a:spcBef>
-              <a:spcAft>
-                <a:spcPts val="400"/>
-              </a:spcAft>
-            </a:pPr>
-            <a:r>
-              <a:rPr sz="1200" b="1" i="0">
-                <a:solidFill>
-                  <a:srgbClr val="161616"/>
-                </a:solidFill>
-                <a:latin typeface="Consolas"/>
-              </a:rPr>
-              <a:t>erp-payments</a:t>
-            </a:r>
-          </a:p>
-        </p:txBody>
-      </p:sp>
-      <p:sp>
-        <p:nvSpPr>
-          <p:cNvPr id="11" name="Rounded Rectangle 10"/>
-          <p:cNvSpPr/>
-          <p:nvPr/>
-        </p:nvSpPr>
-        <p:spPr>
-          <a:xfrm>
-            <a:off x="7680960" y="3145536"/>
-            <a:ext cx="3840480" cy="457200"/>
-          </a:xfrm>
-          <a:prstGeom prst="roundRect">
-            <a:avLst>
-              <a:gd name="adj" fmla="val 6000"/>
-            </a:avLst>
-          </a:prstGeom>
-          <a:solidFill>
-            <a:srgbClr val="F2F4F8"/>
-          </a:solidFill>
-          <a:ln w="12700">
-            <a:solidFill>
-              <a:srgbClr val="D0D7E2"/>
-            </a:solidFill>
-          </a:ln>
-          <a:effectLst/>
-        </p:spPr>
-        <p:style>
-          <a:lnRef idx="1">
-            <a:schemeClr val="accent1"/>
-          </a:lnRef>
-          <a:fillRef idx="3">
-            <a:schemeClr val="accent1"/>
-          </a:fillRef>
-          <a:effectRef idx="2">
-            <a:schemeClr val="accent1"/>
-          </a:effectRef>
-          <a:fontRef idx="minor">
-            <a:schemeClr val="lt1"/>
-          </a:fontRef>
-        </p:style>
-        <p:txBody>
-          <a:bodyPr rtlCol="0" anchor="ctr"/>
-          <a:lstStyle/>
-          <a:p>
-            <a:pPr algn="ctr"/>
-          </a:p>
-        </p:txBody>
-      </p:sp>
-      <p:sp>
-        <p:nvSpPr>
-          <p:cNvPr id="12" name="TextBox 11"/>
-          <p:cNvSpPr txBox="1"/>
-          <p:nvPr/>
-        </p:nvSpPr>
-        <p:spPr>
-          <a:xfrm>
-            <a:off x="7863840" y="3182112"/>
-            <a:ext cx="3566160" cy="384048"/>
-          </a:xfrm>
-          <a:prstGeom prst="rect">
-            <a:avLst/>
-          </a:prstGeom>
-          <a:noFill/>
-        </p:spPr>
-        <p:txBody>
-          <a:bodyPr wrap="square" anchor="ctr" lIns="0" rIns="0" tIns="0" bIns="0">
-            <a:spAutoFit/>
-          </a:bodyPr>
-          <a:lstStyle/>
-          <a:p>
-            <a:pPr algn="l">
-              <a:lnSpc>
-                <a:spcPct val="100000"/>
-              </a:lnSpc>
-              <a:spcBef>
-                <a:spcPts val="0"/>
-              </a:spcBef>
-              <a:spcAft>
-                <a:spcPts val="400"/>
-              </a:spcAft>
-            </a:pPr>
-            <a:r>
-              <a:rPr sz="1200" b="1" i="0">
-                <a:solidFill>
-                  <a:srgbClr val="161616"/>
-                </a:solidFill>
-                <a:latin typeface="Consolas"/>
-              </a:rPr>
-              <a:t>policy-docs</a:t>
-            </a:r>
-          </a:p>
-        </p:txBody>
-      </p:sp>
-      <p:sp>
-        <p:nvSpPr>
-          <p:cNvPr id="13" name="Rounded Rectangle 12"/>
-          <p:cNvSpPr/>
-          <p:nvPr/>
-        </p:nvSpPr>
-        <p:spPr>
-          <a:xfrm>
-            <a:off x="7680960" y="3712464"/>
-            <a:ext cx="3840480" cy="457200"/>
-          </a:xfrm>
-          <a:prstGeom prst="roundRect">
-            <a:avLst>
-              <a:gd name="adj" fmla="val 6000"/>
-            </a:avLst>
-          </a:prstGeom>
-          <a:solidFill>
-            <a:srgbClr val="F2F4F8"/>
-          </a:solidFill>
-          <a:ln w="12700">
-            <a:solidFill>
-              <a:srgbClr val="D0D7E2"/>
-            </a:solidFill>
-          </a:ln>
-          <a:effectLst/>
-        </p:spPr>
-        <p:style>
-          <a:lnRef idx="1">
-            <a:schemeClr val="accent1"/>
-          </a:lnRef>
-          <a:fillRef idx="3">
-            <a:schemeClr val="accent1"/>
-          </a:fillRef>
-          <a:effectRef idx="2">
-            <a:schemeClr val="accent1"/>
-          </a:effectRef>
-          <a:fontRef idx="minor">
-            <a:schemeClr val="lt1"/>
-          </a:fontRef>
-        </p:style>
-        <p:txBody>
-          <a:bodyPr rtlCol="0" anchor="ctr"/>
-          <a:lstStyle/>
-          <a:p>
-            <a:pPr algn="ctr"/>
-          </a:p>
-        </p:txBody>
-      </p:sp>
-      <p:sp>
-        <p:nvSpPr>
-          <p:cNvPr id="14" name="TextBox 13"/>
-          <p:cNvSpPr txBox="1"/>
-          <p:nvPr/>
-        </p:nvSpPr>
-        <p:spPr>
-          <a:xfrm>
-            <a:off x="7863840" y="3749039"/>
-            <a:ext cx="3566160" cy="384048"/>
-          </a:xfrm>
-          <a:prstGeom prst="rect">
-            <a:avLst/>
-          </a:prstGeom>
-          <a:noFill/>
-        </p:spPr>
-        <p:txBody>
-          <a:bodyPr wrap="square" anchor="ctr" lIns="0" rIns="0" tIns="0" bIns="0">
-            <a:spAutoFit/>
-          </a:bodyPr>
-          <a:lstStyle/>
-          <a:p>
-            <a:pPr algn="l">
-              <a:lnSpc>
-                <a:spcPct val="100000"/>
-              </a:lnSpc>
-              <a:spcBef>
-                <a:spcPts val="0"/>
-              </a:spcBef>
-              <a:spcAft>
-                <a:spcPts val="400"/>
-              </a:spcAft>
-            </a:pPr>
-            <a:r>
-              <a:rPr sz="1200" b="1" i="0">
-                <a:solidFill>
-                  <a:srgbClr val="161616"/>
-                </a:solidFill>
-                <a:latin typeface="Consolas"/>
-              </a:rPr>
-              <a:t>notify</a:t>
-            </a:r>
-          </a:p>
-        </p:txBody>
-      </p:sp>
-      <p:sp>
-        <p:nvSpPr>
-          <p:cNvPr id="15" name="Rounded Rectangle 14"/>
-          <p:cNvSpPr/>
-          <p:nvPr/>
-        </p:nvSpPr>
-        <p:spPr>
-          <a:xfrm>
-            <a:off x="7680960" y="4279392"/>
-            <a:ext cx="3840480" cy="457200"/>
-          </a:xfrm>
-          <a:prstGeom prst="roundRect">
-            <a:avLst>
-              <a:gd name="adj" fmla="val 6000"/>
-            </a:avLst>
-          </a:prstGeom>
-          <a:solidFill>
-            <a:srgbClr val="F2F4F8"/>
-          </a:solidFill>
-          <a:ln w="12700">
-            <a:solidFill>
-              <a:srgbClr val="D0D7E2"/>
-            </a:solidFill>
-          </a:ln>
-          <a:effectLst/>
-        </p:spPr>
-        <p:style>
-          <a:lnRef idx="1">
-            <a:schemeClr val="accent1"/>
-          </a:lnRef>
-          <a:fillRef idx="3">
-            <a:schemeClr val="accent1"/>
-          </a:fillRef>
-          <a:effectRef idx="2">
-            <a:schemeClr val="accent1"/>
-          </a:effectRef>
-          <a:fontRef idx="minor">
-            <a:schemeClr val="lt1"/>
-          </a:fontRef>
-        </p:style>
-        <p:txBody>
-          <a:bodyPr rtlCol="0" anchor="ctr"/>
-          <a:lstStyle/>
-          <a:p>
-            <a:pPr algn="ctr"/>
-          </a:p>
-        </p:txBody>
-      </p:sp>
-      <p:sp>
-        <p:nvSpPr>
-          <p:cNvPr id="16" name="TextBox 15"/>
-          <p:cNvSpPr txBox="1"/>
-          <p:nvPr/>
-        </p:nvSpPr>
-        <p:spPr>
-          <a:xfrm>
-            <a:off x="7863840" y="4315968"/>
-            <a:ext cx="3566160" cy="384048"/>
-          </a:xfrm>
-          <a:prstGeom prst="rect">
-            <a:avLst/>
-          </a:prstGeom>
-          <a:noFill/>
-        </p:spPr>
-        <p:txBody>
-          <a:bodyPr wrap="square" anchor="ctr" lIns="0" rIns="0" tIns="0" bIns="0">
-            <a:spAutoFit/>
-          </a:bodyPr>
-          <a:lstStyle/>
-          <a:p>
-            <a:pPr algn="l">
-              <a:lnSpc>
-                <a:spcPct val="100000"/>
-              </a:lnSpc>
-              <a:spcBef>
-                <a:spcPts val="0"/>
-              </a:spcBef>
-              <a:spcAft>
-                <a:spcPts val="400"/>
-              </a:spcAft>
-            </a:pPr>
-            <a:r>
-              <a:rPr sz="1200" b="1" i="0">
-                <a:solidFill>
-                  <a:srgbClr val="161616"/>
-                </a:solidFill>
-                <a:latin typeface="Consolas"/>
-              </a:rPr>
-              <a:t>a2a_auditor</a:t>
-            </a:r>
-          </a:p>
-        </p:txBody>
-      </p:sp>
-      <p:sp>
-        <p:nvSpPr>
-          <p:cNvPr id="17" name="Rounded Rectangle 16"/>
-          <p:cNvSpPr/>
-          <p:nvPr/>
-        </p:nvSpPr>
-        <p:spPr>
-          <a:xfrm>
-            <a:off x="7680960" y="4846320"/>
-            <a:ext cx="3840480" cy="457200"/>
-          </a:xfrm>
-          <a:prstGeom prst="roundRect">
-            <a:avLst>
-              <a:gd name="adj" fmla="val 6000"/>
-            </a:avLst>
-          </a:prstGeom>
-          <a:solidFill>
-            <a:srgbClr val="F2F4F8"/>
-          </a:solidFill>
-          <a:ln w="12700">
-            <a:solidFill>
-              <a:srgbClr val="D0D7E2"/>
-            </a:solidFill>
-          </a:ln>
-          <a:effectLst/>
-        </p:spPr>
-        <p:style>
-          <a:lnRef idx="1">
-            <a:schemeClr val="accent1"/>
-          </a:lnRef>
-          <a:fillRef idx="3">
-            <a:schemeClr val="accent1"/>
-          </a:fillRef>
-          <a:effectRef idx="2">
-            <a:schemeClr val="accent1"/>
-          </a:effectRef>
-          <a:fontRef idx="minor">
-            <a:schemeClr val="lt1"/>
-          </a:fontRef>
-        </p:style>
-        <p:txBody>
-          <a:bodyPr rtlCol="0" anchor="ctr"/>
-          <a:lstStyle/>
-          <a:p>
-            <a:pPr algn="ctr"/>
-          </a:p>
-        </p:txBody>
-      </p:sp>
-      <p:sp>
-        <p:nvSpPr>
-          <p:cNvPr id="18" name="TextBox 17"/>
-          <p:cNvSpPr txBox="1"/>
-          <p:nvPr/>
-        </p:nvSpPr>
-        <p:spPr>
-          <a:xfrm>
-            <a:off x="7863840" y="4882896"/>
-            <a:ext cx="3566160" cy="384048"/>
-          </a:xfrm>
-          <a:prstGeom prst="rect">
-            <a:avLst/>
-          </a:prstGeom>
-          <a:noFill/>
-        </p:spPr>
-        <p:txBody>
-          <a:bodyPr wrap="square" anchor="ctr" lIns="0" rIns="0" tIns="0" bIns="0">
-            <a:spAutoFit/>
-          </a:bodyPr>
-          <a:lstStyle/>
-          <a:p>
-            <a:pPr algn="l">
-              <a:lnSpc>
-                <a:spcPct val="100000"/>
-              </a:lnSpc>
-              <a:spcBef>
-                <a:spcPts val="0"/>
-              </a:spcBef>
-              <a:spcAft>
-                <a:spcPts val="400"/>
-              </a:spcAft>
-            </a:pPr>
-            <a:r>
-              <a:rPr sz="1200" b="1" i="0">
-                <a:solidFill>
-                  <a:srgbClr val="161616"/>
-                </a:solidFill>
-                <a:latin typeface="Consolas"/>
-              </a:rPr>
-              <a:t>a2a_payments</a:t>
-            </a:r>
-          </a:p>
-        </p:txBody>
-      </p:sp>
-      <p:sp>
-        <p:nvSpPr>
-          <p:cNvPr id="19" name="Rounded Rectangle 18"/>
+      <p:pic>
+        <p:nvPicPr>
+          <p:cNvPr id="7" name="Picture 6" descr="architecture.png"/>
+          <p:cNvPicPr>
+            <a:picLocks noChangeAspect="1"/>
+          </p:cNvPicPr>
+          <p:nvPr/>
+        </p:nvPicPr>
+        <p:blipFill>
+          <a:blip r:embed="rId2"/>
+          <a:stretch>
+            <a:fillRect/>
+          </a:stretch>
+        </p:blipFill>
+        <p:spPr>
+          <a:xfrm>
+            <a:off x="2404731" y="1920240"/>
+            <a:ext cx="7382233" cy="3429000"/>
+          </a:xfrm>
+          <a:prstGeom prst="rect">
+            <a:avLst/>
+          </a:prstGeom>
+        </p:spPr>
+      </p:pic>
+      <p:sp>
+        <p:nvSpPr>
+          <p:cNvPr id="8" name="Rounded Rectangle 7"/>
           <p:cNvSpPr/>
           <p:nvPr/>
         </p:nvSpPr>
@@ -10509,7 +9975,7 @@
       </p:sp>
       <p:sp>
         <p:nvSpPr>
-          <p:cNvPr id="20" name="TextBox 19"/>
+          <p:cNvPr id="9" name="TextBox 8"/>
           <p:cNvSpPr txBox="1"/>
           <p:nvPr/>
         </p:nvSpPr>
@@ -10648,7 +10114,7 @@
       </p:sp>
       <p:sp>
         <p:nvSpPr>
-          <p:cNvPr id="21" name="TextBox 20"/>
+          <p:cNvPr id="10" name="TextBox 9"/>
           <p:cNvSpPr txBox="1"/>
           <p:nvPr/>
         </p:nvSpPr>
@@ -10693,7 +10159,7 @@
       </p:sp>
       <p:sp>
         <p:nvSpPr>
-          <p:cNvPr id="22" name="TextBox 21"/>
+          <p:cNvPr id="11" name="TextBox 10"/>
           <p:cNvSpPr txBox="1"/>
           <p:nvPr/>
         </p:nvSpPr>

</xml_diff>